<commit_message>
docs: B10 embed verified quiz demo recording in pitch deck
Add the 75.5-second edited Chrome-extension demo, preserving the continuous native confirmation and matching redacted proof. Embed the exact MP4 in slide 3 with a PDF poster fallback, reproducible edit manifests, playback checks, and updated presentation notes.

Branch from current main after PR #8 merged; preserve Countersign-revised.pptx. Verified 129 tests, TypeScript build, presentation syntax, full video decode, and deck/PDF validation. Exclude raw recordings, credentials, tooling caches, and Finder metadata.
</commit_message>
<xml_diff>
--- a/docs/presentation/Countersign.pptx
+++ b/docs/presentation/Countersign.pptx
@@ -708,6 +708,7 @@
 Slide 3 — Same task. Different boundary.
 On screen: a large video/demo region, with labels Governance off and Governance on. End on an enlarged crop of the actual accepted-proof event, not the whole log.
 This is the main event. Use the same ChatGPT extension, Chrome profile, demo user, and rehearsed quiz request in both instances. Keep the mode indicator visible. The full sequence is in §5.
+Current delivery: introduce this as a recorded demo, then play the completed clip and narrate its four beats. The confirmation shown happened in that recording. The clip takes 75.5 seconds of the 1:45 slot, leaving 29.5 seconds for introduction and wrap; live/hybrid delivery is optional.
 Narrate four beats:
 1. “Without governance, the assistant completes the quiz submission in the learner's session.” Show the real result; do not claim all assistants or all prompts behave this way.
 2. “Now the app requires a human. The assistant can prepare the answers, but submission waits for confirmation.” Let the real prompt/status remain visible briefly.
@@ -716,9 +717,11 @@
 Landing line: “The important part isn't whether the assistant looks human. It's that the application requires human confirmation.”
 Do not suggest the quiz is graded, that presence proves the answers are the learner's work, or that a waiting browser prompt is itself a logged `blocked` HTTP request.
 PRODUCTION / EVIDENCE NOTES
-DEMO SLOT — no video is embedded. The picture is a static governed-quiz UI reference. Switch to your prepared Chrome tabs, or replace the dark panel with your real recording. The OFF/ON pills contain localhost hyperlinks; pre-open Chrome because hyperlinks use the OS default browser. Never describe this still as the selected extension submitting or a human touching a sensor.
-Demo schedule: 20s ungoverned result; 30s governed preparation; 25s fresh prompt/confirmation/result; 20s matching audit; 10s landing line. In a hybrid handoff, explain where the recording ends and live confirmation starts. Do not pre-issue a challenge.
-If live progress stalls for ~10 seconds, use the backup. Show the actual human-verified event and assertion ID from THAT run. Do not substitute UI/test evidence.</a:t>
+RECORDED DEMO — 75.5 seconds, embedded in this slide. In Slide Show, click the video itself to play. Narrate live; the MP4 is intentionally silent. Keep Countersign-demo.mp4 as the standalone fallback. Do not call this a live interaction.
+Video clock: 0:00–0:30 governance off; 0:30–1:04.5 governance on; 1:04.5–1:15.5 matching audit. Use the remaining 29.5 seconds of the 1:45 slide allocation for introduction and landing line.
+The recordings show the real Chrome ChatGPT extension and native Touch ID UI, not a virtual authenticator. Waiting intervals are trimmed. Governed source 34–56.5 seconds remains contiguous at real time; a spatial zoom changes framing only. The final eight seconds are explicitly a still from this same recording's audit at source time 78 seconds. Session data is cropped out and the credential identifier is visibly masked.
+Matching actual assertion: asr_20a3eda1-bc17-4d87-ba58-2e44c966eaf8; UP=true, UV=true, age=6775ms. This verifies participation, not authorship, comprehension, or which finger was used. Native prompt, result, and audit are not substituted from another run. See demo-edit.json, demo-video.json, and recording-session.md.
+PowerPoint/Keynote playback on the presenting laptop and the timed rehearsal still need a human check.</a:t>
             </a:r>
             <a:endParaRPr lang="en-US" dirty="0"/>
           </a:p>
@@ -3661,7 +3664,7 @@
     <p:bg>
       <p:bgPr>
         <a:solidFill>
-          <a:srgbClr val="F3F6FA"/>
+          <a:srgbClr val="10243A"/>
         </a:solidFill>
       </p:bgPr>
     </p:bg>
@@ -3687,8 +3690,8 @@
         </p:nvSpPr>
         <p:spPr>
           <a:xfrm>
-            <a:off x="658368" y="384048"/>
-            <a:ext cx="7772400" cy="201168"/>
+            <a:off x="493776" y="109728"/>
+            <a:ext cx="8887968" cy="320040"/>
           </a:xfrm>
           <a:prstGeom prst="rect">
             <a:avLst/>
@@ -3704,17 +3707,17 @@
               <a:buNone/>
             </a:pPr>
             <a:r>
-              <a:rPr lang="en-US" sz="1150" b="1" spc="120" kern="0" dirty="0">
-                <a:solidFill>
-                  <a:srgbClr val="006D68"/>
-                </a:solidFill>
-                <a:latin typeface="Arial" pitchFamily="34" charset="0"/>
-                <a:ea typeface="Arial" pitchFamily="34" charset="-122"/>
-                <a:cs typeface="Arial" pitchFamily="34" charset="-120"/>
-              </a:rPr>
-              <a:t>SO WHAT / THE DEMO</a:t>
-            </a:r>
-            <a:endParaRPr lang="en-US" sz="1150" dirty="0"/>
+              <a:rPr lang="en-US" sz="2300" b="1" dirty="0">
+                <a:solidFill>
+                  <a:srgbClr val="FFFFFF"/>
+                </a:solidFill>
+                <a:latin typeface="Arial" pitchFamily="34" charset="0"/>
+                <a:ea typeface="Arial" pitchFamily="34" charset="-122"/>
+                <a:cs typeface="Arial" pitchFamily="34" charset="-120"/>
+              </a:rPr>
+              <a:t>Same task. Different boundary.</a:t>
+            </a:r>
+            <a:endParaRPr lang="en-US" sz="2300" dirty="0"/>
           </a:p>
         </p:txBody>
       </p:sp>
@@ -3726,8 +3729,8 @@
         </p:nvSpPr>
         <p:spPr>
           <a:xfrm>
-            <a:off x="9464040" y="365760"/>
-            <a:ext cx="2075688" cy="256032"/>
+            <a:off x="9646920" y="173736"/>
+            <a:ext cx="2029968" cy="219456"/>
           </a:xfrm>
           <a:prstGeom prst="rect">
             <a:avLst/>
@@ -3743,229 +3746,23 @@
               <a:buNone/>
             </a:pPr>
             <a:r>
-              <a:rPr lang="en-US" sz="1500" b="1" dirty="0">
-                <a:solidFill>
-                  <a:srgbClr val="10243A"/>
-                </a:solidFill>
-                <a:latin typeface="Arial" pitchFamily="34" charset="0"/>
-                <a:ea typeface="Arial" pitchFamily="34" charset="-122"/>
-                <a:cs typeface="Arial" pitchFamily="34" charset="-120"/>
-              </a:rPr>
-              <a:t>countersign.</a:t>
-            </a:r>
-            <a:endParaRPr lang="en-US" sz="1500" dirty="0"/>
-          </a:p>
-        </p:txBody>
-      </p:sp>
-      <p:sp>
-        <p:nvSpPr>
-          <p:cNvPr id="4" name="Shape 2"/>
-          <p:cNvSpPr/>
-          <p:nvPr/>
-        </p:nvSpPr>
-        <p:spPr>
-          <a:xfrm>
-            <a:off x="658368" y="6437376"/>
-            <a:ext cx="10872216" cy="0"/>
-          </a:xfrm>
-          <a:prstGeom prst="line">
-            <a:avLst/>
-          </a:prstGeom>
-          <a:noFill/>
-          <a:ln w="8890">
-            <a:solidFill>
-              <a:srgbClr val="DCE4EE"/>
-            </a:solidFill>
-            <a:prstDash val="solid"/>
-          </a:ln>
-        </p:spPr>
-      </p:sp>
-      <p:sp>
-        <p:nvSpPr>
-          <p:cNvPr id="5" name="Text 3"/>
-          <p:cNvSpPr/>
-          <p:nvPr/>
-        </p:nvSpPr>
-        <p:spPr>
-          <a:xfrm>
-            <a:off x="676656" y="6537960"/>
-            <a:ext cx="8412480" cy="146304"/>
-          </a:xfrm>
-          <a:prstGeom prst="rect">
-            <a:avLst/>
-          </a:prstGeom>
-          <a:noFill/>
-          <a:ln/>
-        </p:spPr>
-        <p:txBody>
-          <a:bodyPr wrap="square" lIns="0" tIns="0" rIns="0" bIns="0" rtlCol="0" anchor="ctr"/>
-          <a:lstStyle/>
-          <a:p>
-            <a:pPr indent="0" marL="0">
-              <a:buNone/>
-            </a:pPr>
-            <a:r>
-              <a:rPr lang="en-US" sz="850" spc="110" kern="0" dirty="0">
-                <a:solidFill>
-                  <a:srgbClr val="54647B"/>
-                </a:solidFill>
-                <a:latin typeface="Arial" pitchFamily="34" charset="0"/>
-                <a:ea typeface="Arial" pitchFamily="34" charset="-122"/>
-                <a:cs typeface="Arial" pitchFamily="34" charset="-120"/>
-              </a:rPr>
-              <a:t>HUMAN VERIFICATION FOR WEB APPS</a:t>
-            </a:r>
-            <a:endParaRPr lang="en-US" sz="850" dirty="0"/>
-          </a:p>
-        </p:txBody>
-      </p:sp>
-      <p:sp>
-        <p:nvSpPr>
-          <p:cNvPr id="6" name="Text 4"/>
-          <p:cNvSpPr/>
-          <p:nvPr/>
-        </p:nvSpPr>
-        <p:spPr>
-          <a:xfrm>
-            <a:off x="11027664" y="6519672"/>
-            <a:ext cx="475488" cy="182880"/>
-          </a:xfrm>
-          <a:prstGeom prst="rect">
-            <a:avLst/>
-          </a:prstGeom>
-          <a:noFill/>
-          <a:ln/>
-        </p:spPr>
-        <p:txBody>
-          <a:bodyPr wrap="square" lIns="0" tIns="0" rIns="0" bIns="0" rtlCol="0" anchor="ctr"/>
-          <a:lstStyle/>
-          <a:p>
-            <a:pPr algn="r" indent="0" marL="0">
-              <a:buNone/>
-            </a:pPr>
-            <a:r>
-              <a:rPr lang="en-US" sz="1000" dirty="0">
-                <a:solidFill>
-                  <a:srgbClr val="54647B"/>
-                </a:solidFill>
-                <a:latin typeface="Arial" pitchFamily="34" charset="0"/>
-                <a:ea typeface="Arial" pitchFamily="34" charset="-122"/>
-                <a:cs typeface="Arial" pitchFamily="34" charset="-120"/>
-              </a:rPr>
-              <a:t>03</a:t>
-            </a:r>
-            <a:endParaRPr lang="en-US" sz="1000" dirty="0"/>
-          </a:p>
-        </p:txBody>
-      </p:sp>
-      <p:sp>
-        <p:nvSpPr>
-          <p:cNvPr id="7" name="Text 5"/>
-          <p:cNvSpPr/>
-          <p:nvPr/>
-        </p:nvSpPr>
-        <p:spPr>
-          <a:xfrm>
-            <a:off x="658368" y="969264"/>
-            <a:ext cx="10927080" cy="704088"/>
-          </a:xfrm>
-          <a:prstGeom prst="rect">
-            <a:avLst/>
-          </a:prstGeom>
-          <a:noFill/>
-          <a:ln/>
-        </p:spPr>
-        <p:txBody>
-          <a:bodyPr wrap="square" lIns="0" tIns="0" rIns="0" bIns="0" rtlCol="0" anchor="ctr"/>
-          <a:lstStyle/>
-          <a:p>
-            <a:pPr indent="0" marL="0">
-              <a:buNone/>
-            </a:pPr>
-            <a:r>
-              <a:rPr lang="en-US" sz="3800" b="1" dirty="0">
-                <a:solidFill>
-                  <a:srgbClr val="10243A"/>
-                </a:solidFill>
-                <a:latin typeface="Arial" pitchFamily="34" charset="0"/>
-                <a:ea typeface="Arial" pitchFamily="34" charset="-122"/>
-                <a:cs typeface="Arial" pitchFamily="34" charset="-120"/>
-              </a:rPr>
-              <a:t>Same task. Different boundary.</a:t>
-            </a:r>
-            <a:endParaRPr lang="en-US" sz="3800" dirty="0"/>
-          </a:p>
-        </p:txBody>
-      </p:sp>
-      <p:sp>
-        <p:nvSpPr>
-          <p:cNvPr id="8" name="Text 6"/>
-          <p:cNvSpPr/>
-          <p:nvPr/>
-        </p:nvSpPr>
-        <p:spPr>
-          <a:xfrm>
-            <a:off x="685800" y="1719072"/>
-            <a:ext cx="8686800" cy="320040"/>
-          </a:xfrm>
-          <a:prstGeom prst="rect">
-            <a:avLst/>
-          </a:prstGeom>
-          <a:noFill/>
-          <a:ln/>
-        </p:spPr>
-        <p:txBody>
-          <a:bodyPr wrap="square" lIns="0" tIns="0" rIns="0" bIns="0" rtlCol="0" anchor="ctr"/>
-          <a:lstStyle/>
-          <a:p>
-            <a:pPr indent="0" marL="0">
-              <a:buNone/>
-            </a:pPr>
-            <a:r>
-              <a:rPr lang="en-US" sz="1800" dirty="0">
-                <a:solidFill>
-                  <a:srgbClr val="54647B"/>
-                </a:solidFill>
-                <a:latin typeface="Arial" pitchFamily="34" charset="0"/>
-                <a:ea typeface="Arial" pitchFamily="34" charset="-122"/>
-                <a:cs typeface="Arial" pitchFamily="34" charset="-120"/>
-              </a:rPr>
-              <a:t>ChatGPT extension · Chrome</a:t>
-            </a:r>
-            <a:endParaRPr lang="en-US" sz="1800" dirty="0"/>
-          </a:p>
-        </p:txBody>
-      </p:sp>
-      <p:sp>
-        <p:nvSpPr>
-          <p:cNvPr id="9" name="Shape 7"/>
-          <p:cNvSpPr/>
-          <p:nvPr/>
-        </p:nvSpPr>
-        <p:spPr>
-          <a:xfrm>
-            <a:off x="685800" y="2258568"/>
-            <a:ext cx="10826496" cy="3712464"/>
-          </a:xfrm>
-          <a:prstGeom prst="roundRect">
-            <a:avLst>
-              <a:gd name="adj" fmla="val 2956"/>
-            </a:avLst>
-          </a:prstGeom>
-          <a:solidFill>
-            <a:srgbClr val="10243A"/>
-          </a:solidFill>
-          <a:ln w="12700">
-            <a:solidFill>
-              <a:srgbClr val="10243A"/>
-            </a:solidFill>
-            <a:prstDash val="solid"/>
-          </a:ln>
-        </p:spPr>
+              <a:rPr lang="en-US" sz="1200" b="1" dirty="0">
+                <a:solidFill>
+                  <a:srgbClr val="BCF58A"/>
+                </a:solidFill>
+                <a:latin typeface="Arial" pitchFamily="34" charset="0"/>
+                <a:ea typeface="Arial" pitchFamily="34" charset="-122"/>
+                <a:cs typeface="Arial" pitchFamily="34" charset="-120"/>
+              </a:rPr>
+              <a:t>RECORDED · 1:15</a:t>
+            </a:r>
+            <a:endParaRPr lang="en-US" sz="1200" dirty="0"/>
+          </a:p>
+        </p:txBody>
       </p:sp>
       <p:pic>
         <p:nvPicPr>
-          <p:cNvPr id="10" name="Image 0" descr="Real governed quiz UI crop; no recorded extension or native prompt.">    </p:cNvPr>
+          <p:cNvPr id="4" name="Image 0" descr="Static preview of the real recorded native prompt; the PPT video overlays this image.">    </p:cNvPr>
           <p:cNvPicPr>
             <a:picLocks noChangeAspect="1"/>
           </p:cNvPicPr>
@@ -3979,370 +3776,47 @@
         </p:blipFill>
         <p:spPr>
           <a:xfrm>
-            <a:off x="932688" y="2542032"/>
-            <a:ext cx="5751576" cy="2935224"/>
+            <a:off x="493776" y="557784"/>
+            <a:ext cx="11192256" cy="6295644"/>
           </a:xfrm>
           <a:prstGeom prst="rect">
             <a:avLst/>
           </a:prstGeom>
         </p:spPr>
       </p:pic>
-      <p:sp>
-        <p:nvSpPr>
-          <p:cNvPr id="11" name="Text 8"/>
-          <p:cNvSpPr/>
-          <p:nvPr/>
-        </p:nvSpPr>
-        <p:spPr>
-          <a:xfrm>
-            <a:off x="1005840" y="5596128"/>
-            <a:ext cx="5669280" cy="182880"/>
-          </a:xfrm>
-          <a:prstGeom prst="rect">
-            <a:avLst/>
-          </a:prstGeom>
-          <a:noFill/>
-          <a:ln/>
-        </p:spPr>
-        <p:txBody>
-          <a:bodyPr wrap="square" lIns="0" tIns="0" rIns="0" bIns="0" rtlCol="0" anchor="ctr"/>
-          <a:lstStyle/>
-          <a:p>
-            <a:pPr indent="0" marL="0">
-              <a:buNone/>
-            </a:pPr>
-            <a:r>
-              <a:rPr lang="en-US" sz="1050" dirty="0">
-                <a:solidFill>
-                  <a:srgbClr val="8CA5B6"/>
-                </a:solidFill>
-                <a:latin typeface="Arial" pitchFamily="34" charset="0"/>
-                <a:ea typeface="Arial" pitchFamily="34" charset="-122"/>
-                <a:cs typeface="Arial" pitchFamily="34" charset="-120"/>
-              </a:rPr>
-              <a:t>Governed quiz · UI reference</a:t>
-            </a:r>
-            <a:endParaRPr lang="en-US" sz="1050" dirty="0"/>
-          </a:p>
-        </p:txBody>
-      </p:sp>
-      <p:sp>
-        <p:nvSpPr>
-          <p:cNvPr id="12" name="Shape 9"/>
-          <p:cNvSpPr/>
-          <p:nvPr/>
-        </p:nvSpPr>
-        <p:spPr>
-          <a:xfrm>
-            <a:off x="7095744" y="2542032"/>
-            <a:ext cx="1828800" cy="384048"/>
-          </a:xfrm>
-          <a:prstGeom prst="roundRect">
-            <a:avLst>
-              <a:gd name="adj" fmla="val 28571"/>
-            </a:avLst>
-          </a:prstGeom>
-          <a:solidFill>
-            <a:srgbClr val="17354A"/>
-          </a:solidFill>
-          <a:ln w="12700">
-            <a:solidFill>
-              <a:srgbClr val="17354A"/>
-            </a:solidFill>
-            <a:prstDash val="solid"/>
-          </a:ln>
-        </p:spPr>
-      </p:sp>
-      <p:sp>
-        <p:nvSpPr>
-          <p:cNvPr id="13" name="Text 10">
-            <a:hlinkClick r:id="rId2" tooltip="Open the ungoverned quiz"/>
+      <p:pic>
+        <p:nvPicPr>
+          <p:cNvPr id="4" name="Recorded quiz demo — governance off/on, native confirmation, matching audit">
+            <a:hlinkClick r:id="" action="ppaction://media"/>
           </p:cNvPr>
-          <p:cNvSpPr/>
-          <p:nvPr/>
-        </p:nvSpPr>
-        <p:spPr>
-          <a:xfrm>
-            <a:off x="7178040" y="2560320"/>
-            <a:ext cx="1664208" cy="338328"/>
-          </a:xfrm>
-          <a:prstGeom prst="rect">
-            <a:avLst/>
-          </a:prstGeom>
-          <a:noFill/>
-          <a:ln/>
-        </p:spPr>
-        <p:txBody>
-          <a:bodyPr wrap="square" lIns="0" tIns="0" rIns="0" bIns="0" rtlCol="0" anchor="ctr"/>
-          <a:lstStyle/>
-          <a:p>
-            <a:pPr algn="ctr" indent="0" marL="0">
-              <a:buNone/>
-            </a:pPr>
-            <a:r>
-              <a:rPr lang="en-US" sz="1230" b="1" u="sng" dirty="0">
-                <a:solidFill>
-                  <a:srgbClr val="FFFFFF"/>
-                </a:solidFill>
-                <a:latin typeface="Arial" pitchFamily="34" charset="0"/>
-                <a:ea typeface="Arial" pitchFamily="34" charset="-122"/>
-                <a:cs typeface="Arial" pitchFamily="34" charset="-120"/>
-                <a:hlinkClick r:id="rId2" invalidUrl="" action="" tgtFrame="" tooltip="Open the ungoverned quiz" history="1" highlightClick="0" endSnd="0">
-                  <a:extLst>
-                    <a:ext uri="{A12FA001-AC4F-418D-AE19-62706E023703}">
-                      <ahyp:hlinkClr xmlns:ahyp="http://schemas.microsoft.com/office/drawing/2018/hyperlinkcolor" val="tx"/>
-                    </a:ext>
-                  </a:extLst>
-                </a:hlinkClick>
-              </a:rPr>
-              <a:t>Governance off</a:t>
-            </a:r>
-            <a:endParaRPr lang="en-US" sz="1230" dirty="0"/>
-          </a:p>
-        </p:txBody>
-      </p:sp>
-      <p:sp>
-        <p:nvSpPr>
-          <p:cNvPr id="14" name="Shape 11"/>
-          <p:cNvSpPr/>
-          <p:nvPr/>
-        </p:nvSpPr>
-        <p:spPr>
-          <a:xfrm>
-            <a:off x="9098280" y="2542032"/>
-            <a:ext cx="1947672" cy="384048"/>
-          </a:xfrm>
-          <a:prstGeom prst="roundRect">
-            <a:avLst>
-              <a:gd name="adj" fmla="val 28571"/>
-            </a:avLst>
-          </a:prstGeom>
-          <a:solidFill>
-            <a:srgbClr val="BCF58A"/>
-          </a:solidFill>
-          <a:ln w="12700">
-            <a:solidFill>
-              <a:srgbClr val="BCF58A"/>
-            </a:solidFill>
-            <a:prstDash val="solid"/>
-          </a:ln>
-        </p:spPr>
-      </p:sp>
-      <p:sp>
-        <p:nvSpPr>
-          <p:cNvPr id="15" name="Text 12">
-            <a:hlinkClick r:id="rId3" tooltip="Open the governed quiz"/>
-          </p:cNvPr>
-          <p:cNvSpPr/>
-          <p:nvPr/>
-        </p:nvSpPr>
-        <p:spPr>
-          <a:xfrm>
-            <a:off x="9180576" y="2560320"/>
-            <a:ext cx="1783080" cy="338328"/>
-          </a:xfrm>
-          <a:prstGeom prst="rect">
-            <a:avLst/>
-          </a:prstGeom>
-          <a:noFill/>
-          <a:ln/>
-        </p:spPr>
-        <p:txBody>
-          <a:bodyPr wrap="square" lIns="0" tIns="0" rIns="0" bIns="0" rtlCol="0" anchor="ctr"/>
-          <a:lstStyle/>
-          <a:p>
-            <a:pPr algn="ctr" indent="0" marL="0">
-              <a:buNone/>
-            </a:pPr>
-            <a:r>
-              <a:rPr lang="en-US" sz="1230" b="1" u="sng" dirty="0">
-                <a:solidFill>
-                  <a:srgbClr val="10243A"/>
-                </a:solidFill>
-                <a:latin typeface="Arial" pitchFamily="34" charset="0"/>
-                <a:ea typeface="Arial" pitchFamily="34" charset="-122"/>
-                <a:cs typeface="Arial" pitchFamily="34" charset="-120"/>
-                <a:hlinkClick r:id="rId3" invalidUrl="" action="" tgtFrame="" tooltip="Open the governed quiz" history="1" highlightClick="0" endSnd="0">
-                  <a:extLst>
-                    <a:ext uri="{A12FA001-AC4F-418D-AE19-62706E023703}">
-                      <ahyp:hlinkClr xmlns:ahyp="http://schemas.microsoft.com/office/drawing/2018/hyperlinkcolor" val="tx"/>
-                    </a:ext>
-                  </a:extLst>
-                </a:hlinkClick>
-              </a:rPr>
-              <a:t>Governance on</a:t>
-            </a:r>
-            <a:endParaRPr lang="en-US" sz="1230" dirty="0"/>
-          </a:p>
-        </p:txBody>
-      </p:sp>
-      <p:sp>
-        <p:nvSpPr>
-          <p:cNvPr id="16" name="Shape 13"/>
-          <p:cNvSpPr/>
-          <p:nvPr/>
-        </p:nvSpPr>
-        <p:spPr>
-          <a:xfrm>
-            <a:off x="8549640" y="3273552"/>
-            <a:ext cx="896112" cy="896112"/>
-          </a:xfrm>
-          <a:prstGeom prst="ellipse">
-            <a:avLst/>
-          </a:prstGeom>
-          <a:solidFill>
-            <a:srgbClr val="17354A"/>
-          </a:solidFill>
-          <a:ln w="12700">
-            <a:solidFill>
-              <a:srgbClr val="8CA5B6"/>
-            </a:solidFill>
-            <a:prstDash val="solid"/>
-          </a:ln>
-        </p:spPr>
-      </p:sp>
-      <p:sp>
-        <p:nvSpPr>
-          <p:cNvPr id="17" name="Shape 14"/>
-          <p:cNvSpPr/>
-          <p:nvPr/>
-        </p:nvSpPr>
-        <p:spPr>
-          <a:xfrm rot="5400000">
-            <a:off x="8887968" y="3538728"/>
-            <a:ext cx="274320" cy="320040"/>
-          </a:xfrm>
-          <a:prstGeom prst="triangle">
-            <a:avLst/>
-          </a:prstGeom>
-          <a:solidFill>
-            <a:srgbClr val="BCF58A"/>
-          </a:solidFill>
-          <a:ln w="12700">
-            <a:solidFill>
-              <a:srgbClr val="BCF58A"/>
-            </a:solidFill>
-            <a:prstDash val="solid"/>
-          </a:ln>
-        </p:spPr>
-      </p:sp>
-      <p:sp>
-        <p:nvSpPr>
-          <p:cNvPr id="18" name="Text 15"/>
-          <p:cNvSpPr/>
-          <p:nvPr/>
-        </p:nvSpPr>
-        <p:spPr>
-          <a:xfrm>
-            <a:off x="7114032" y="4498848"/>
-            <a:ext cx="3977640" cy="402336"/>
-          </a:xfrm>
-          <a:prstGeom prst="rect">
-            <a:avLst/>
-          </a:prstGeom>
-          <a:noFill/>
-          <a:ln/>
-        </p:spPr>
-        <p:txBody>
-          <a:bodyPr wrap="square" lIns="0" tIns="0" rIns="0" bIns="0" rtlCol="0" anchor="ctr"/>
-          <a:lstStyle/>
-          <a:p>
-            <a:pPr algn="ctr" indent="0" marL="0">
-              <a:buNone/>
-            </a:pPr>
-            <a:r>
-              <a:rPr lang="en-US" sz="2800" b="1" dirty="0">
-                <a:solidFill>
-                  <a:srgbClr val="FFFFFF"/>
-                </a:solidFill>
-                <a:latin typeface="Arial" pitchFamily="34" charset="0"/>
-                <a:ea typeface="Arial" pitchFamily="34" charset="-122"/>
-                <a:cs typeface="Arial" pitchFamily="34" charset="-120"/>
-              </a:rPr>
-              <a:t>Live demo</a:t>
-            </a:r>
-            <a:endParaRPr lang="en-US" sz="2800" dirty="0"/>
-          </a:p>
-        </p:txBody>
-      </p:sp>
-      <p:sp>
-        <p:nvSpPr>
-          <p:cNvPr id="19" name="Text 16"/>
-          <p:cNvSpPr/>
-          <p:nvPr/>
-        </p:nvSpPr>
-        <p:spPr>
-          <a:xfrm>
-            <a:off x="7114032" y="4956048"/>
-            <a:ext cx="3977640" cy="301752"/>
-          </a:xfrm>
-          <a:prstGeom prst="rect">
-            <a:avLst/>
-          </a:prstGeom>
-          <a:noFill/>
-          <a:ln/>
-        </p:spPr>
-        <p:txBody>
-          <a:bodyPr wrap="square" lIns="0" tIns="0" rIns="0" bIns="0" rtlCol="0" anchor="ctr"/>
-          <a:lstStyle/>
-          <a:p>
-            <a:pPr algn="ctr" indent="0" marL="0">
-              <a:buNone/>
-            </a:pPr>
-            <a:r>
-              <a:rPr lang="en-US" sz="1700" dirty="0">
-                <a:solidFill>
-                  <a:srgbClr val="8CA5B6"/>
-                </a:solidFill>
-                <a:latin typeface="Arial" pitchFamily="34" charset="0"/>
-                <a:ea typeface="Arial" pitchFamily="34" charset="-122"/>
-                <a:cs typeface="Arial" pitchFamily="34" charset="-120"/>
-              </a:rPr>
-              <a:t>or insert your recording</a:t>
-            </a:r>
-            <a:endParaRPr lang="en-US" sz="1700" dirty="0"/>
-          </a:p>
-        </p:txBody>
-      </p:sp>
-      <p:sp>
-        <p:nvSpPr>
-          <p:cNvPr id="20" name="Text 17"/>
-          <p:cNvSpPr/>
-          <p:nvPr/>
-        </p:nvSpPr>
-        <p:spPr>
-          <a:xfrm>
-            <a:off x="7013448" y="5550408"/>
-            <a:ext cx="4187952" cy="201168"/>
-          </a:xfrm>
-          <a:prstGeom prst="rect">
-            <a:avLst/>
-          </a:prstGeom>
-          <a:noFill/>
-          <a:ln/>
-        </p:spPr>
-        <p:txBody>
-          <a:bodyPr wrap="square" lIns="0" tIns="0" rIns="0" bIns="0" rtlCol="0" anchor="ctr"/>
-          <a:lstStyle/>
-          <a:p>
-            <a:pPr algn="ctr" indent="0" marL="0">
-              <a:buNone/>
-            </a:pPr>
-            <a:r>
-              <a:rPr lang="en-US" sz="1220" dirty="0">
-                <a:solidFill>
-                  <a:srgbClr val="BCF58A"/>
-                </a:solidFill>
-                <a:latin typeface="Arial" pitchFamily="34" charset="0"/>
-                <a:ea typeface="Arial" pitchFamily="34" charset="-122"/>
-                <a:cs typeface="Arial" pitchFamily="34" charset="-120"/>
-              </a:rPr>
-              <a:t>Prepare → Confirm → Inspect proof</a:t>
-            </a:r>
-            <a:endParaRPr lang="en-US" sz="1220" dirty="0"/>
-          </a:p>
-        </p:txBody>
-      </p:sp>
+          <p:cNvPicPr>
+            <a:picLocks noChangeAspect="1"/>
+          </p:cNvPicPr>
+          <p:nvPr>
+            <a:videoFile r:link="rId2"/>
+            <p:extLst>
+              <p:ext uri="{DAA4B4D4-6D71-4841-9C94-3DE7FCFB9230}">
+                <p14:media xmlns:p14="http://schemas.microsoft.com/office/powerpoint/2010/main" r:embed="rId3"/>
+              </p:ext>
+            </p:extLst>
+          </p:nvPr>
+        </p:nvPicPr>
+        <p:blipFill>
+          <a:blip r:embed="rId4"/>
+          <a:stretch>
+            <a:fillRect/>
+          </a:stretch>
+        </p:blipFill>
+        <p:spPr>
+          <a:xfrm>
+            <a:off x="493776" y="557784"/>
+            <a:ext cx="11192256" cy="6295644"/>
+          </a:xfrm>
+          <a:prstGeom prst="rect">
+            <a:avLst/>
+          </a:prstGeom>
+        </p:spPr>
+      </p:pic>
     </p:spTree>
   </p:cSld>
   <p:clrMapOvr>

</xml_diff>